<commit_message>
Switch W02 slide 17 Python venv section to uv
Co-Authored-By: Claude Opus 5 (1M context) <noreply@anthropic.com>
Claude-Session: https://claude.ai/code/session_011B6qNutNoSLKABhXbsQmfa
</commit_message>
<xml_diff>
--- a/courseware/202609_ADS_W02_VM_Shell_DevEnv.pptx
+++ b/courseware/202609_ADS_W02_VM_Shell_DevEnv.pptx
@@ -7178,7 +7178,7 @@
                 <a:latin typeface="Segoe UI"/>
                 <a:ea typeface="微软雅黑"/>
               </a:rPr>
-              <a:t>Python 虚拟环境</a:t>
+              <a:t>Python 虚拟环境（uv）</a:t>
             </a:r>
           </a:p>
         </p:txBody>
@@ -7314,7 +7314,7 @@
                 <a:latin typeface="Consolas"/>
                 <a:ea typeface="Consolas"/>
               </a:rPr>
-              <a:t>python3 -m venv .venv                 # 创建</a:t>
+              <a:t>uv python install 3.14 --default     # 安装 Python（由 uv 管理）</a:t>
             </a:r>
           </a:p>
           <a:p>
@@ -7337,7 +7337,7 @@
                 <a:latin typeface="Consolas"/>
                 <a:ea typeface="Consolas"/>
               </a:rPr>
-              <a:t>source .venv/bin/activate             # 启用（macOS / Linux）</a:t>
+              <a:t>uv init --no-package MyPython        # 新建项目（--no-package 不能省）</a:t>
             </a:r>
           </a:p>
           <a:p>
@@ -7360,7 +7360,7 @@
                 <a:latin typeface="Consolas"/>
                 <a:ea typeface="Consolas"/>
               </a:rPr>
-              <a:t>.venv\Scripts\activate                # 启用（Windows PowerShell）</a:t>
+              <a:t>cd MyPython</a:t>
             </a:r>
           </a:p>
           <a:p>
@@ -7383,7 +7383,7 @@
                 <a:latin typeface="Consolas"/>
                 <a:ea typeface="Consolas"/>
               </a:rPr>
-              <a:t>pip install numpy matplotlib          # 装包，只影响这个环境</a:t>
+              <a:t>uv add numpy matplotlib              # 装包，写入 pyproject.toml / uv.lock</a:t>
             </a:r>
           </a:p>
           <a:p>
@@ -7406,7 +7406,7 @@
                 <a:latin typeface="Consolas"/>
                 <a:ea typeface="Consolas"/>
               </a:rPr>
-              <a:t>pip freeze &gt; requirements.txt         # 导出依赖</a:t>
+              <a:t>uv run main.py                       # 运行，自动使用 .venv，无需 activate</a:t>
             </a:r>
           </a:p>
           <a:p>
@@ -7429,7 +7429,7 @@
                 <a:latin typeface="Consolas"/>
                 <a:ea typeface="Consolas"/>
               </a:rPr>
-              <a:t>deactivate                            # 退出</a:t>
+              <a:t>uv remove numpy                      # 卸载包</a:t>
             </a:r>
           </a:p>
           <a:p>
@@ -7452,7 +7452,7 @@
                 <a:latin typeface="Consolas"/>
                 <a:ea typeface="Consolas"/>
               </a:rPr>
-              <a:t> </a:t>
+              <a:t># 环境坏了 / 换了电脑：删掉 .venv 重建</a:t>
             </a:r>
           </a:p>
           <a:p>
@@ -7475,7 +7475,7 @@
                 <a:latin typeface="Consolas"/>
                 <a:ea typeface="Consolas"/>
               </a:rPr>
-              <a:t># Windows 若提示无法运行脚本：</a:t>
+              <a:t>rm -rf .venv &amp;&amp; uv sync                      # macOS / Linux</a:t>
             </a:r>
           </a:p>
           <a:p>
@@ -7498,7 +7498,7 @@
                 <a:latin typeface="Consolas"/>
                 <a:ea typeface="Consolas"/>
               </a:rPr>
-              <a:t># Set-ExecutionPolicy -Scope CurrentUser -ExecutionPolicy RemoteSigned</a:t>
+              <a:t>Remove-Item -Recurse -Force .venv; uv sync   # Windows PowerShell</a:t>
             </a:r>
           </a:p>
         </p:txBody>
@@ -7541,7 +7541,7 @@
                 <a:latin typeface="Segoe UI"/>
                 <a:ea typeface="微软雅黑"/>
               </a:rPr>
-              <a:t>不同项目依赖不同版本的包，虚拟环境把它们隔离开</a:t>
+              <a:t>虚拟环境隔离不同项目的包；uv 一个工具管好 Python 版本、.venv 和第三方包</a:t>
             </a:r>
           </a:p>
         </p:txBody>

</xml_diff>